<commit_message>
docs: add screenshots to README and final presentation slide deck
</commit_message>
<xml_diff>
--- a/HobbyFi_Presentation.pptx
+++ b/HobbyFi_Presentation.pptx
@@ -15,6 +15,7 @@
     <p:sldId id="263" r:id="rId14"/>
     <p:sldId id="264" r:id="rId15"/>
     <p:sldId id="265" r:id="rId16"/>
+    <p:sldId id="266" r:id="rId17"/>
   </p:sldIdLst>
   <p:sldSz cx="14630400" cy="8229600" type="screen4x3"/>
   <p:notesSz cx="6858000" cy="9144000"/>
@@ -3298,6 +3299,459 @@
     <p:bg>
       <p:bgPr>
         <a:solidFill>
+          <a:srgbClr val="F8FAFC"/>
+        </a:solidFill>
+        <a:effectLst/>
+      </p:bgPr>
+    </p:bg>
+    <p:spTree>
+      <p:nvGrpSpPr>
+        <p:cNvPr id="1" name=""/>
+        <p:cNvGrpSpPr/>
+        <p:nvPr/>
+      </p:nvGrpSpPr>
+      <p:grpSpPr/>
+      <p:sp>
+        <p:nvSpPr>
+          <p:cNvPr id="2" name="Rectangle 1"/>
+          <p:cNvSpPr/>
+          <p:nvPr/>
+        </p:nvSpPr>
+        <p:spPr>
+          <a:xfrm>
+            <a:off x="0" y="0"/>
+            <a:ext cx="14630400" cy="365760"/>
+          </a:xfrm>
+          <a:prstGeom prst="rect">
+            <a:avLst/>
+          </a:prstGeom>
+          <a:solidFill>
+            <a:srgbClr val="4F46E5"/>
+          </a:solidFill>
+          <a:ln>
+            <a:noFill/>
+          </a:ln>
+        </p:spPr>
+        <p:style>
+          <a:lnRef idx="1">
+            <a:schemeClr val="accent1"/>
+          </a:lnRef>
+          <a:fillRef idx="3">
+            <a:schemeClr val="accent1"/>
+          </a:fillRef>
+          <a:effectRef idx="2">
+            <a:schemeClr val="accent1"/>
+          </a:effectRef>
+          <a:fontRef idx="minor">
+            <a:schemeClr val="lt1"/>
+          </a:fontRef>
+        </p:style>
+        <p:txBody>
+          <a:bodyPr rtlCol="0" anchor="ctr"/>
+          <a:lstStyle/>
+          <a:p>
+            <a:pPr algn="ctr"/>
+          </a:p>
+        </p:txBody>
+      </p:sp>
+      <p:sp>
+        <p:nvSpPr>
+          <p:cNvPr id="3" name="TextBox 2"/>
+          <p:cNvSpPr txBox="1"/>
+          <p:nvPr/>
+        </p:nvSpPr>
+        <p:spPr>
+          <a:xfrm>
+            <a:off x="731520" y="548640"/>
+            <a:ext cx="13167360" cy="914400"/>
+          </a:xfrm>
+          <a:prstGeom prst="rect">
+            <a:avLst/>
+          </a:prstGeom>
+          <a:noFill/>
+        </p:spPr>
+        <p:txBody>
+          <a:bodyPr wrap="square" lIns="0" tIns="0" rIns="0" bIns="0">
+            <a:spAutoFit/>
+          </a:bodyPr>
+          <a:lstStyle/>
+          <a:p>
+            <a:pPr>
+              <a:defRPr sz="3600" b="1">
+                <a:solidFill>
+                  <a:srgbClr val="0F172A"/>
+                </a:solidFill>
+                <a:latin typeface="Trebuchet MS"/>
+              </a:defRPr>
+            </a:pPr>
+            <a:r>
+              <a:t>Future Production-Ready Roadmap</a:t>
+            </a:r>
+          </a:p>
+        </p:txBody>
+      </p:sp>
+      <p:sp>
+        <p:nvSpPr>
+          <p:cNvPr id="4" name="Rounded Rectangle 3"/>
+          <p:cNvSpPr/>
+          <p:nvPr/>
+        </p:nvSpPr>
+        <p:spPr>
+          <a:xfrm>
+            <a:off x="731520" y="1645920"/>
+            <a:ext cx="4023360" cy="5852160"/>
+          </a:xfrm>
+          <a:prstGeom prst="roundRect">
+            <a:avLst/>
+          </a:prstGeom>
+          <a:solidFill>
+            <a:srgbClr val="FFFFFF"/>
+          </a:solidFill>
+          <a:ln w="12700">
+            <a:solidFill>
+              <a:srgbClr val="E2E8F0"/>
+            </a:solidFill>
+          </a:ln>
+        </p:spPr>
+        <p:style>
+          <a:lnRef idx="1">
+            <a:schemeClr val="accent1"/>
+          </a:lnRef>
+          <a:fillRef idx="3">
+            <a:schemeClr val="accent1"/>
+          </a:fillRef>
+          <a:effectRef idx="2">
+            <a:schemeClr val="accent1"/>
+          </a:effectRef>
+          <a:fontRef idx="minor">
+            <a:schemeClr val="lt1"/>
+          </a:fontRef>
+        </p:style>
+        <p:txBody>
+          <a:bodyPr rtlCol="0" anchor="ctr"/>
+          <a:lstStyle/>
+          <a:p>
+            <a:pPr algn="ctr"/>
+          </a:p>
+        </p:txBody>
+      </p:sp>
+      <p:sp>
+        <p:nvSpPr>
+          <p:cNvPr id="5" name="TextBox 4"/>
+          <p:cNvSpPr txBox="1"/>
+          <p:nvPr/>
+        </p:nvSpPr>
+        <p:spPr>
+          <a:xfrm>
+            <a:off x="1005840" y="1920240"/>
+            <a:ext cx="3474720" cy="5303520"/>
+          </a:xfrm>
+          <a:prstGeom prst="rect">
+            <a:avLst/>
+          </a:prstGeom>
+          <a:noFill/>
+        </p:spPr>
+        <p:txBody>
+          <a:bodyPr wrap="square" lIns="0" tIns="0" rIns="0" bIns="0">
+            <a:spAutoFit/>
+          </a:bodyPr>
+          <a:lstStyle/>
+          <a:p>
+            <a:pPr>
+              <a:spcAft>
+                <a:spcPts val="1400"/>
+              </a:spcAft>
+              <a:defRPr sz="2000" b="1">
+                <a:solidFill>
+                  <a:srgbClr val="4F46E5"/>
+                </a:solidFill>
+                <a:latin typeface="Segoe UI"/>
+              </a:defRPr>
+            </a:pPr>
+            <a:r>
+              <a:t>Phase 1: Authorization Hardening</a:t>
+            </a:r>
+          </a:p>
+          <a:p>
+            <a:pPr>
+              <a:spcAft>
+                <a:spcPts val="1600"/>
+              </a:spcAft>
+              <a:defRPr sz="1400">
+                <a:solidFill>
+                  <a:srgbClr val="475569"/>
+                </a:solidFill>
+                <a:latin typeface="Segoe UI"/>
+              </a:defRPr>
+            </a:pPr>
+            <a:r>
+              <a:t>• Replace the current simulated X-Vendor-ID header auth with secure JWT or OAuth 2.0 flows.</a:t>
+            </a:r>
+          </a:p>
+          <a:p>
+            <a:pPr>
+              <a:spcAft>
+                <a:spcPts val="1600"/>
+              </a:spcAft>
+              <a:defRPr sz="1400">
+                <a:solidFill>
+                  <a:srgbClr val="475569"/>
+                </a:solidFill>
+                <a:latin typeface="Segoe UI"/>
+              </a:defRPr>
+            </a:pPr>
+            <a:r>
+              <a:t>• Implement Role-Based Access Control (RBAC): Admin roles auto-execute, while Staff roles route to Human-in-the-Loop approvals.</a:t>
+            </a:r>
+          </a:p>
+        </p:txBody>
+      </p:sp>
+      <p:sp>
+        <p:nvSpPr>
+          <p:cNvPr id="6" name="Rounded Rectangle 5"/>
+          <p:cNvSpPr/>
+          <p:nvPr/>
+        </p:nvSpPr>
+        <p:spPr>
+          <a:xfrm>
+            <a:off x="5303520" y="1645920"/>
+            <a:ext cx="4023360" cy="5852160"/>
+          </a:xfrm>
+          <a:prstGeom prst="roundRect">
+            <a:avLst/>
+          </a:prstGeom>
+          <a:solidFill>
+            <a:srgbClr val="FFFFFF"/>
+          </a:solidFill>
+          <a:ln w="12700">
+            <a:solidFill>
+              <a:srgbClr val="E2E8F0"/>
+            </a:solidFill>
+          </a:ln>
+        </p:spPr>
+        <p:style>
+          <a:lnRef idx="1">
+            <a:schemeClr val="accent1"/>
+          </a:lnRef>
+          <a:fillRef idx="3">
+            <a:schemeClr val="accent1"/>
+          </a:fillRef>
+          <a:effectRef idx="2">
+            <a:schemeClr val="accent1"/>
+          </a:effectRef>
+          <a:fontRef idx="minor">
+            <a:schemeClr val="lt1"/>
+          </a:fontRef>
+        </p:style>
+        <p:txBody>
+          <a:bodyPr rtlCol="0" anchor="ctr"/>
+          <a:lstStyle/>
+          <a:p>
+            <a:pPr algn="ctr"/>
+          </a:p>
+        </p:txBody>
+      </p:sp>
+      <p:sp>
+        <p:nvSpPr>
+          <p:cNvPr id="7" name="TextBox 6"/>
+          <p:cNvSpPr txBox="1"/>
+          <p:nvPr/>
+        </p:nvSpPr>
+        <p:spPr>
+          <a:xfrm>
+            <a:off x="5577840" y="1920240"/>
+            <a:ext cx="3474720" cy="5303520"/>
+          </a:xfrm>
+          <a:prstGeom prst="rect">
+            <a:avLst/>
+          </a:prstGeom>
+          <a:noFill/>
+        </p:spPr>
+        <p:txBody>
+          <a:bodyPr wrap="square" lIns="0" tIns="0" rIns="0" bIns="0">
+            <a:spAutoFit/>
+          </a:bodyPr>
+          <a:lstStyle/>
+          <a:p>
+            <a:pPr>
+              <a:spcAft>
+                <a:spcPts val="1400"/>
+              </a:spcAft>
+              <a:defRPr sz="2000" b="1">
+                <a:solidFill>
+                  <a:srgbClr val="4F46E5"/>
+                </a:solidFill>
+                <a:latin typeface="Segoe UI"/>
+              </a:defRPr>
+            </a:pPr>
+            <a:r>
+              <a:t>Phase 2: UX &amp; Stream Upgrades</a:t>
+            </a:r>
+          </a:p>
+          <a:p>
+            <a:pPr>
+              <a:spcAft>
+                <a:spcPts val="1600"/>
+              </a:spcAft>
+              <a:defRPr sz="1400">
+                <a:solidFill>
+                  <a:srgbClr val="475569"/>
+                </a:solidFill>
+                <a:latin typeface="Segoe UI"/>
+              </a:defRPr>
+            </a:pPr>
+            <a:r>
+              <a:t>• Upgrade current REST endpoints to WebSockets to support real-time LLM token streaming.</a:t>
+            </a:r>
+          </a:p>
+          <a:p>
+            <a:pPr>
+              <a:spcAft>
+                <a:spcPts val="1600"/>
+              </a:spcAft>
+              <a:defRPr sz="1400">
+                <a:solidFill>
+                  <a:srgbClr val="475569"/>
+                </a:solidFill>
+                <a:latin typeface="Segoe UI"/>
+              </a:defRPr>
+            </a:pPr>
+            <a:r>
+              <a:t>• Add rich UI approval card breakdowns to preview exact user/game database details prior to execution.</a:t>
+            </a:r>
+          </a:p>
+        </p:txBody>
+      </p:sp>
+      <p:sp>
+        <p:nvSpPr>
+          <p:cNvPr id="8" name="Rounded Rectangle 7"/>
+          <p:cNvSpPr/>
+          <p:nvPr/>
+        </p:nvSpPr>
+        <p:spPr>
+          <a:xfrm>
+            <a:off x="9875520" y="1645920"/>
+            <a:ext cx="4023360" cy="5852160"/>
+          </a:xfrm>
+          <a:prstGeom prst="roundRect">
+            <a:avLst/>
+          </a:prstGeom>
+          <a:solidFill>
+            <a:srgbClr val="FFFFFF"/>
+          </a:solidFill>
+          <a:ln w="12700">
+            <a:solidFill>
+              <a:srgbClr val="E2E8F0"/>
+            </a:solidFill>
+          </a:ln>
+        </p:spPr>
+        <p:style>
+          <a:lnRef idx="1">
+            <a:schemeClr val="accent1"/>
+          </a:lnRef>
+          <a:fillRef idx="3">
+            <a:schemeClr val="accent1"/>
+          </a:fillRef>
+          <a:effectRef idx="2">
+            <a:schemeClr val="accent1"/>
+          </a:effectRef>
+          <a:fontRef idx="minor">
+            <a:schemeClr val="lt1"/>
+          </a:fontRef>
+        </p:style>
+        <p:txBody>
+          <a:bodyPr rtlCol="0" anchor="ctr"/>
+          <a:lstStyle/>
+          <a:p>
+            <a:pPr algn="ctr"/>
+          </a:p>
+        </p:txBody>
+      </p:sp>
+      <p:sp>
+        <p:nvSpPr>
+          <p:cNvPr id="9" name="TextBox 8"/>
+          <p:cNvSpPr txBox="1"/>
+          <p:nvPr/>
+        </p:nvSpPr>
+        <p:spPr>
+          <a:xfrm>
+            <a:off x="10149840" y="1920240"/>
+            <a:ext cx="3474720" cy="5303520"/>
+          </a:xfrm>
+          <a:prstGeom prst="rect">
+            <a:avLst/>
+          </a:prstGeom>
+          <a:noFill/>
+        </p:spPr>
+        <p:txBody>
+          <a:bodyPr wrap="square" lIns="0" tIns="0" rIns="0" bIns="0">
+            <a:spAutoFit/>
+          </a:bodyPr>
+          <a:lstStyle/>
+          <a:p>
+            <a:pPr>
+              <a:spcAft>
+                <a:spcPts val="1400"/>
+              </a:spcAft>
+              <a:defRPr sz="2000" b="1">
+                <a:solidFill>
+                  <a:srgbClr val="4F46E5"/>
+                </a:solidFill>
+                <a:latin typeface="Segoe UI"/>
+              </a:defRPr>
+            </a:pPr>
+            <a:r>
+              <a:t>Phase 3: Database &amp; CI Hardening</a:t>
+            </a:r>
+          </a:p>
+          <a:p>
+            <a:pPr>
+              <a:spcAft>
+                <a:spcPts val="1600"/>
+              </a:spcAft>
+              <a:defRPr sz="1400">
+                <a:solidFill>
+                  <a:srgbClr val="475569"/>
+                </a:solidFill>
+                <a:latin typeface="Segoe UI"/>
+              </a:defRPr>
+            </a:pPr>
+            <a:r>
+              <a:t>• Transition startup-based database creation to version-controlled Alembic migrations.</a:t>
+            </a:r>
+          </a:p>
+          <a:p>
+            <a:pPr>
+              <a:spcAft>
+                <a:spcPts val="1600"/>
+              </a:spcAft>
+              <a:defRPr sz="1400">
+                <a:solidFill>
+                  <a:srgbClr val="475569"/>
+                </a:solidFill>
+                <a:latin typeface="Segoe UI"/>
+              </a:defRPr>
+            </a:pPr>
+            <a:r>
+              <a:t>• Build a CI pipeline that runs safety tests automatically on pull requests.</a:t>
+            </a:r>
+          </a:p>
+        </p:txBody>
+      </p:sp>
+    </p:spTree>
+  </p:cSld>
+  <p:clrMapOvr>
+    <a:masterClrMapping/>
+  </p:clrMapOvr>
+</p:sld>
+</file>
+
+<file path=ppt/slides/slide11.xml><?xml version="1.0" encoding="utf-8"?>
+<p:sld xmlns:a="http://schemas.openxmlformats.org/drawingml/2006/main" xmlns:p="http://schemas.openxmlformats.org/presentationml/2006/main" xmlns:r="http://schemas.openxmlformats.org/officeDocument/2006/relationships">
+  <p:cSld>
+    <p:bg>
+      <p:bgPr>
+        <a:solidFill>
           <a:srgbClr val="0F172A"/>
         </a:solidFill>
         <a:effectLst/>
@@ -6420,7 +6874,7 @@
               </a:defRPr>
             </a:pPr>
             <a:r>
-              <a:t>New Feature: Background Document Ingestion Pipeline</a:t>
+              <a:t>The Copilot Interface in Action</a:t>
             </a:r>
           </a:p>
         </p:txBody>
@@ -6434,140 +6888,7 @@
         <p:spPr>
           <a:xfrm>
             <a:off x="731520" y="1645920"/>
-            <a:ext cx="13167360" cy="2011680"/>
-          </a:xfrm>
-          <a:prstGeom prst="roundRect">
-            <a:avLst/>
-          </a:prstGeom>
-          <a:solidFill>
-            <a:srgbClr val="FFFFFF"/>
-          </a:solidFill>
-          <a:ln w="12700">
-            <a:solidFill>
-              <a:srgbClr val="E2E8F0"/>
-            </a:solidFill>
-          </a:ln>
-        </p:spPr>
-        <p:style>
-          <a:lnRef idx="1">
-            <a:schemeClr val="accent1"/>
-          </a:lnRef>
-          <a:fillRef idx="3">
-            <a:schemeClr val="accent1"/>
-          </a:fillRef>
-          <a:effectRef idx="2">
-            <a:schemeClr val="accent1"/>
-          </a:effectRef>
-          <a:fontRef idx="minor">
-            <a:schemeClr val="lt1"/>
-          </a:fontRef>
-        </p:style>
-        <p:txBody>
-          <a:bodyPr rtlCol="0" anchor="ctr"/>
-          <a:lstStyle/>
-          <a:p>
-            <a:pPr algn="ctr"/>
-          </a:p>
-        </p:txBody>
-      </p:sp>
-      <p:sp>
-        <p:nvSpPr>
-          <p:cNvPr id="5" name="TextBox 4"/>
-          <p:cNvSpPr txBox="1"/>
-          <p:nvPr/>
-        </p:nvSpPr>
-        <p:spPr>
-          <a:xfrm>
-            <a:off x="1097280" y="1920240"/>
-            <a:ext cx="12435840" cy="1463040"/>
-          </a:xfrm>
-          <a:prstGeom prst="rect">
-            <a:avLst/>
-          </a:prstGeom>
-          <a:noFill/>
-        </p:spPr>
-        <p:txBody>
-          <a:bodyPr wrap="square" lIns="0" tIns="0" rIns="0" bIns="0">
-            <a:spAutoFit/>
-          </a:bodyPr>
-          <a:lstStyle/>
-          <a:p>
-            <a:pPr>
-              <a:spcAft>
-                <a:spcPts val="800"/>
-              </a:spcAft>
-              <a:defRPr sz="2200" b="1">
-                <a:solidFill>
-                  <a:srgbClr val="4F46E5"/>
-                </a:solidFill>
-                <a:latin typeface="Segoe UI"/>
-              </a:defRPr>
-            </a:pPr>
-            <a:r>
-              <a:t>Asynchronous Support Document Ingestion</a:t>
-            </a:r>
-          </a:p>
-          <a:p>
-            <a:pPr>
-              <a:defRPr sz="1600">
-                <a:solidFill>
-                  <a:srgbClr val="475569"/>
-                </a:solidFill>
-                <a:latin typeface="Segoe UI"/>
-              </a:defRPr>
-            </a:pPr>
-            <a:r>
-              <a:t>In this update, I built and integrated a background document ingestion pipeline (`POST /api/v1/documents/upload`). While the current phase of the Copilot focuses strictly on structured CRM data, this new feature establishes the foundational architecture for future Unstructured RAG capabilities.</a:t>
-            </a:r>
-          </a:p>
-        </p:txBody>
-      </p:sp>
-      <p:sp>
-        <p:nvSpPr>
-          <p:cNvPr id="6" name="TextBox 5"/>
-          <p:cNvSpPr txBox="1"/>
-          <p:nvPr/>
-        </p:nvSpPr>
-        <p:spPr>
-          <a:xfrm>
-            <a:off x="731520" y="3931920"/>
-            <a:ext cx="13167360" cy="365760"/>
-          </a:xfrm>
-          <a:prstGeom prst="rect">
-            <a:avLst/>
-          </a:prstGeom>
-          <a:noFill/>
-        </p:spPr>
-        <p:txBody>
-          <a:bodyPr wrap="square" lIns="0" tIns="0" rIns="0" bIns="0">
-            <a:spAutoFit/>
-          </a:bodyPr>
-          <a:lstStyle/>
-          <a:p>
-            <a:pPr algn="l">
-              <a:defRPr sz="2000" b="1">
-                <a:solidFill>
-                  <a:srgbClr val="0F172A"/>
-                </a:solidFill>
-                <a:latin typeface="Segoe UI"/>
-              </a:defRPr>
-            </a:pPr>
-            <a:r>
-              <a:t>How the Ingestion Pipeline Operates</a:t>
-            </a:r>
-          </a:p>
-        </p:txBody>
-      </p:sp>
-      <p:sp>
-        <p:nvSpPr>
-          <p:cNvPr id="7" name="Rounded Rectangle 6"/>
-          <p:cNvSpPr/>
-          <p:nvPr/>
-        </p:nvSpPr>
-        <p:spPr>
-          <a:xfrm>
-            <a:off x="731520" y="4389120"/>
-            <a:ext cx="3108960" cy="2743200"/>
+            <a:ext cx="6217920" cy="3840480"/>
           </a:xfrm>
           <a:prstGeom prst="roundRect">
             <a:avLst/>
@@ -6603,16 +6924,40 @@
           </a:p>
         </p:txBody>
       </p:sp>
-      <p:sp>
-        <p:nvSpPr>
-          <p:cNvPr id="8" name="TextBox 7"/>
+      <p:pic>
+        <p:nvPicPr>
+          <p:cNvPr id="5" name="Picture 4" descr="chrome_0TWUGEPASU.png"/>
+          <p:cNvPicPr>
+            <a:picLocks noChangeAspect="1"/>
+          </p:cNvPicPr>
+          <p:nvPr/>
+        </p:nvPicPr>
+        <p:blipFill>
+          <a:blip r:embed="rId2"/>
+          <a:stretch>
+            <a:fillRect/>
+          </a:stretch>
+        </p:blipFill>
+        <p:spPr>
+          <a:xfrm>
+            <a:off x="914400" y="1828800"/>
+            <a:ext cx="5852160" cy="3474720"/>
+          </a:xfrm>
+          <a:prstGeom prst="rect">
+            <a:avLst/>
+          </a:prstGeom>
+        </p:spPr>
+      </p:pic>
+      <p:sp>
+        <p:nvSpPr>
+          <p:cNvPr id="6" name="TextBox 5"/>
           <p:cNvSpPr txBox="1"/>
           <p:nvPr/>
         </p:nvSpPr>
         <p:spPr>
           <a:xfrm>
-            <a:off x="914400" y="4663440"/>
-            <a:ext cx="2743200" cy="2194560"/>
+            <a:off x="731520" y="5669280"/>
+            <a:ext cx="6217920" cy="1645920"/>
           </a:xfrm>
           <a:prstGeom prst="rect">
             <a:avLst/>
@@ -6620,16 +6965,16 @@
           <a:noFill/>
         </p:spPr>
         <p:txBody>
-          <a:bodyPr wrap="square" lIns="0" tIns="0" rIns="0" bIns="0">
+          <a:bodyPr wrap="square">
             <a:spAutoFit/>
           </a:bodyPr>
           <a:lstStyle/>
           <a:p>
             <a:pPr>
               <a:spcAft>
-                <a:spcPts val="800"/>
-              </a:spcAft>
-              <a:defRPr sz="1600" b="1">
+                <a:spcPts val="400"/>
+              </a:spcAft>
+              <a:defRPr sz="1800" b="1">
                 <a:solidFill>
                   <a:srgbClr val="4F46E5"/>
                 </a:solidFill>
@@ -6637,12 +6982,12 @@
               </a:defRPr>
             </a:pPr>
             <a:r>
-              <a:t>1. FastAPI Endpoint</a:t>
-            </a:r>
-          </a:p>
-          <a:p>
-            <a:pPr>
-              <a:defRPr sz="1300">
+              <a:t>Interactive Chat Interface</a:t>
+            </a:r>
+          </a:p>
+          <a:p>
+            <a:pPr>
+              <a:defRPr sz="1400">
                 <a:solidFill>
                   <a:srgbClr val="475569"/>
                 </a:solidFill>
@@ -6650,21 +6995,21 @@
               </a:defRPr>
             </a:pPr>
             <a:r>
-              <a:t>Accepts multipart file upload and hands off to FastAPI background task.</a:t>
-            </a:r>
-          </a:p>
-        </p:txBody>
-      </p:sp>
-      <p:sp>
-        <p:nvSpPr>
-          <p:cNvPr id="9" name="Rounded Rectangle 8"/>
+              <a:t>Features dynamic user-scoped conversation turns with runtime mode badges (Gemini mode, Local model, or Fallback responder).</a:t>
+            </a:r>
+          </a:p>
+        </p:txBody>
+      </p:sp>
+      <p:sp>
+        <p:nvSpPr>
+          <p:cNvPr id="7" name="Rounded Rectangle 6"/>
           <p:cNvSpPr/>
           <p:nvPr/>
         </p:nvSpPr>
         <p:spPr>
           <a:xfrm>
-            <a:off x="4023360" y="4389120"/>
-            <a:ext cx="3108960" cy="2743200"/>
+            <a:off x="7680960" y="1645920"/>
+            <a:ext cx="6217920" cy="3840480"/>
           </a:xfrm>
           <a:prstGeom prst="roundRect">
             <a:avLst/>
@@ -6700,16 +7045,40 @@
           </a:p>
         </p:txBody>
       </p:sp>
-      <p:sp>
-        <p:nvSpPr>
-          <p:cNvPr id="10" name="TextBox 9"/>
+      <p:pic>
+        <p:nvPicPr>
+          <p:cNvPr id="8" name="Picture 7" descr="chrome_N0ZVgJtSap.png"/>
+          <p:cNvPicPr>
+            <a:picLocks noChangeAspect="1"/>
+          </p:cNvPicPr>
+          <p:nvPr/>
+        </p:nvPicPr>
+        <p:blipFill>
+          <a:blip r:embed="rId3"/>
+          <a:stretch>
+            <a:fillRect/>
+          </a:stretch>
+        </p:blipFill>
+        <p:spPr>
+          <a:xfrm>
+            <a:off x="7863840" y="1828800"/>
+            <a:ext cx="5852160" cy="3474720"/>
+          </a:xfrm>
+          <a:prstGeom prst="rect">
+            <a:avLst/>
+          </a:prstGeom>
+        </p:spPr>
+      </p:pic>
+      <p:sp>
+        <p:nvSpPr>
+          <p:cNvPr id="9" name="TextBox 8"/>
           <p:cNvSpPr txBox="1"/>
           <p:nvPr/>
         </p:nvSpPr>
         <p:spPr>
           <a:xfrm>
-            <a:off x="4206240" y="4663440"/>
-            <a:ext cx="2743200" cy="2194560"/>
+            <a:off x="7680960" y="5669280"/>
+            <a:ext cx="6217920" cy="1645920"/>
           </a:xfrm>
           <a:prstGeom prst="rect">
             <a:avLst/>
@@ -6717,16 +7086,16 @@
           <a:noFill/>
         </p:spPr>
         <p:txBody>
-          <a:bodyPr wrap="square" lIns="0" tIns="0" rIns="0" bIns="0">
+          <a:bodyPr wrap="square">
             <a:spAutoFit/>
           </a:bodyPr>
           <a:lstStyle/>
           <a:p>
             <a:pPr>
               <a:spcAft>
-                <a:spcPts val="800"/>
-              </a:spcAft>
-              <a:defRPr sz="1600" b="1">
+                <a:spcPts val="400"/>
+              </a:spcAft>
+              <a:defRPr sz="1800" b="1">
                 <a:solidFill>
                   <a:srgbClr val="4F46E5"/>
                 </a:solidFill>
@@ -6734,12 +7103,12 @@
               </a:defRPr>
             </a:pPr>
             <a:r>
-              <a:t>2. Extraction &amp; Clean</a:t>
-            </a:r>
-          </a:p>
-          <a:p>
-            <a:pPr>
-              <a:defRPr sz="1300">
+              <a:t>Human-in-the-Loop Approvals</a:t>
+            </a:r>
+          </a:p>
+          <a:p>
+            <a:pPr>
+              <a:defRPr sz="1400">
                 <a:solidFill>
                   <a:srgbClr val="475569"/>
                 </a:solidFill>
@@ -6747,201 +7116,7 @@
               </a:defRPr>
             </a:pPr>
             <a:r>
-              <a:t>Saves temporarily, extracts text (OCR/Parser), and strips extra whitespace.</a:t>
-            </a:r>
-          </a:p>
-        </p:txBody>
-      </p:sp>
-      <p:sp>
-        <p:nvSpPr>
-          <p:cNvPr id="11" name="Rounded Rectangle 10"/>
-          <p:cNvSpPr/>
-          <p:nvPr/>
-        </p:nvSpPr>
-        <p:spPr>
-          <a:xfrm>
-            <a:off x="7315200" y="4389120"/>
-            <a:ext cx="3108960" cy="2743200"/>
-          </a:xfrm>
-          <a:prstGeom prst="roundRect">
-            <a:avLst/>
-          </a:prstGeom>
-          <a:solidFill>
-            <a:srgbClr val="FFFFFF"/>
-          </a:solidFill>
-          <a:ln w="12700">
-            <a:solidFill>
-              <a:srgbClr val="4F46E5"/>
-            </a:solidFill>
-          </a:ln>
-        </p:spPr>
-        <p:style>
-          <a:lnRef idx="1">
-            <a:schemeClr val="accent1"/>
-          </a:lnRef>
-          <a:fillRef idx="3">
-            <a:schemeClr val="accent1"/>
-          </a:fillRef>
-          <a:effectRef idx="2">
-            <a:schemeClr val="accent1"/>
-          </a:effectRef>
-          <a:fontRef idx="minor">
-            <a:schemeClr val="lt1"/>
-          </a:fontRef>
-        </p:style>
-        <p:txBody>
-          <a:bodyPr rtlCol="0" anchor="ctr"/>
-          <a:lstStyle/>
-          <a:p>
-            <a:pPr algn="ctr"/>
-          </a:p>
-        </p:txBody>
-      </p:sp>
-      <p:sp>
-        <p:nvSpPr>
-          <p:cNvPr id="12" name="TextBox 11"/>
-          <p:cNvSpPr txBox="1"/>
-          <p:nvPr/>
-        </p:nvSpPr>
-        <p:spPr>
-          <a:xfrm>
-            <a:off x="7498080" y="4663440"/>
-            <a:ext cx="2743200" cy="2194560"/>
-          </a:xfrm>
-          <a:prstGeom prst="rect">
-            <a:avLst/>
-          </a:prstGeom>
-          <a:noFill/>
-        </p:spPr>
-        <p:txBody>
-          <a:bodyPr wrap="square" lIns="0" tIns="0" rIns="0" bIns="0">
-            <a:spAutoFit/>
-          </a:bodyPr>
-          <a:lstStyle/>
-          <a:p>
-            <a:pPr>
-              <a:spcAft>
-                <a:spcPts val="800"/>
-              </a:spcAft>
-              <a:defRPr sz="1600" b="1">
-                <a:solidFill>
-                  <a:srgbClr val="4F46E5"/>
-                </a:solidFill>
-                <a:latin typeface="Segoe UI"/>
-              </a:defRPr>
-            </a:pPr>
-            <a:r>
-              <a:t>3. Chunking &amp; Overlap</a:t>
-            </a:r>
-          </a:p>
-          <a:p>
-            <a:pPr>
-              <a:defRPr sz="1300">
-                <a:solidFill>
-                  <a:srgbClr val="475569"/>
-                </a:solidFill>
-                <a:latin typeface="Segoe UI"/>
-              </a:defRPr>
-            </a:pPr>
-            <a:r>
-              <a:t>Chunks clean text using sliding thresholds (15 lines per chunk, 5 lines overlap).</a:t>
-            </a:r>
-          </a:p>
-        </p:txBody>
-      </p:sp>
-      <p:sp>
-        <p:nvSpPr>
-          <p:cNvPr id="13" name="Rounded Rectangle 12"/>
-          <p:cNvSpPr/>
-          <p:nvPr/>
-        </p:nvSpPr>
-        <p:spPr>
-          <a:xfrm>
-            <a:off x="10607040" y="4389120"/>
-            <a:ext cx="3291840" cy="2743200"/>
-          </a:xfrm>
-          <a:prstGeom prst="roundRect">
-            <a:avLst/>
-          </a:prstGeom>
-          <a:solidFill>
-            <a:srgbClr val="FFFFFF"/>
-          </a:solidFill>
-          <a:ln w="12700">
-            <a:solidFill>
-              <a:srgbClr val="4F46E5"/>
-            </a:solidFill>
-          </a:ln>
-        </p:spPr>
-        <p:style>
-          <a:lnRef idx="1">
-            <a:schemeClr val="accent1"/>
-          </a:lnRef>
-          <a:fillRef idx="3">
-            <a:schemeClr val="accent1"/>
-          </a:fillRef>
-          <a:effectRef idx="2">
-            <a:schemeClr val="accent1"/>
-          </a:effectRef>
-          <a:fontRef idx="minor">
-            <a:schemeClr val="lt1"/>
-          </a:fontRef>
-        </p:style>
-        <p:txBody>
-          <a:bodyPr rtlCol="0" anchor="ctr"/>
-          <a:lstStyle/>
-          <a:p>
-            <a:pPr algn="ctr"/>
-          </a:p>
-        </p:txBody>
-      </p:sp>
-      <p:sp>
-        <p:nvSpPr>
-          <p:cNvPr id="14" name="TextBox 13"/>
-          <p:cNvSpPr txBox="1"/>
-          <p:nvPr/>
-        </p:nvSpPr>
-        <p:spPr>
-          <a:xfrm>
-            <a:off x="10789920" y="4663440"/>
-            <a:ext cx="2926080" cy="2194560"/>
-          </a:xfrm>
-          <a:prstGeom prst="rect">
-            <a:avLst/>
-          </a:prstGeom>
-          <a:noFill/>
-        </p:spPr>
-        <p:txBody>
-          <a:bodyPr wrap="square" lIns="0" tIns="0" rIns="0" bIns="0">
-            <a:spAutoFit/>
-          </a:bodyPr>
-          <a:lstStyle/>
-          <a:p>
-            <a:pPr>
-              <a:spcAft>
-                <a:spcPts val="800"/>
-              </a:spcAft>
-              <a:defRPr sz="1600" b="1">
-                <a:solidFill>
-                  <a:srgbClr val="4F46E5"/>
-                </a:solidFill>
-                <a:latin typeface="Segoe UI"/>
-              </a:defRPr>
-            </a:pPr>
-            <a:r>
-              <a:t>4. pgvector Embedding</a:t>
-            </a:r>
-          </a:p>
-          <a:p>
-            <a:pPr>
-              <a:defRPr sz="1300">
-                <a:solidFill>
-                  <a:srgbClr val="475569"/>
-                </a:solidFill>
-                <a:latin typeface="Segoe UI"/>
-              </a:defRPr>
-            </a:pPr>
-            <a:r>
-              <a:t>Embeds chunk text and persists to PostgreSQL with pgvector embeddings.</a:t>
+              <a:t>Mutating CRM requests return a draft card where changes are locked until explicit approval, ensuring strict transactional safety.</a:t>
             </a:r>
           </a:p>
         </p:txBody>
@@ -7046,7 +7221,7 @@
               </a:defRPr>
             </a:pPr>
             <a:r>
-              <a:t>DevOps Constraints &amp; Performance Optimizations</a:t>
+              <a:t>New Feature: Background Document Ingestion Pipeline</a:t>
             </a:r>
           </a:p>
         </p:txBody>
@@ -7060,7 +7235,140 @@
         <p:spPr>
           <a:xfrm>
             <a:off x="731520" y="1645920"/>
-            <a:ext cx="6217920" cy="5852160"/>
+            <a:ext cx="13167360" cy="2011680"/>
+          </a:xfrm>
+          <a:prstGeom prst="roundRect">
+            <a:avLst/>
+          </a:prstGeom>
+          <a:solidFill>
+            <a:srgbClr val="FFFFFF"/>
+          </a:solidFill>
+          <a:ln w="12700">
+            <a:solidFill>
+              <a:srgbClr val="E2E8F0"/>
+            </a:solidFill>
+          </a:ln>
+        </p:spPr>
+        <p:style>
+          <a:lnRef idx="1">
+            <a:schemeClr val="accent1"/>
+          </a:lnRef>
+          <a:fillRef idx="3">
+            <a:schemeClr val="accent1"/>
+          </a:fillRef>
+          <a:effectRef idx="2">
+            <a:schemeClr val="accent1"/>
+          </a:effectRef>
+          <a:fontRef idx="minor">
+            <a:schemeClr val="lt1"/>
+          </a:fontRef>
+        </p:style>
+        <p:txBody>
+          <a:bodyPr rtlCol="0" anchor="ctr"/>
+          <a:lstStyle/>
+          <a:p>
+            <a:pPr algn="ctr"/>
+          </a:p>
+        </p:txBody>
+      </p:sp>
+      <p:sp>
+        <p:nvSpPr>
+          <p:cNvPr id="5" name="TextBox 4"/>
+          <p:cNvSpPr txBox="1"/>
+          <p:nvPr/>
+        </p:nvSpPr>
+        <p:spPr>
+          <a:xfrm>
+            <a:off x="1097280" y="1920240"/>
+            <a:ext cx="12435840" cy="1463040"/>
+          </a:xfrm>
+          <a:prstGeom prst="rect">
+            <a:avLst/>
+          </a:prstGeom>
+          <a:noFill/>
+        </p:spPr>
+        <p:txBody>
+          <a:bodyPr wrap="square" lIns="0" tIns="0" rIns="0" bIns="0">
+            <a:spAutoFit/>
+          </a:bodyPr>
+          <a:lstStyle/>
+          <a:p>
+            <a:pPr>
+              <a:spcAft>
+                <a:spcPts val="800"/>
+              </a:spcAft>
+              <a:defRPr sz="2200" b="1">
+                <a:solidFill>
+                  <a:srgbClr val="4F46E5"/>
+                </a:solidFill>
+                <a:latin typeface="Segoe UI"/>
+              </a:defRPr>
+            </a:pPr>
+            <a:r>
+              <a:t>Asynchronous Support Document Ingestion</a:t>
+            </a:r>
+          </a:p>
+          <a:p>
+            <a:pPr>
+              <a:defRPr sz="1600">
+                <a:solidFill>
+                  <a:srgbClr val="475569"/>
+                </a:solidFill>
+                <a:latin typeface="Segoe UI"/>
+              </a:defRPr>
+            </a:pPr>
+            <a:r>
+              <a:t>In this update, I built and integrated a background document ingestion pipeline (`POST /api/v1/documents/upload`). While the current phase of the Copilot focuses strictly on structured CRM data, this new feature establishes the foundational architecture for future Unstructured RAG capabilities.</a:t>
+            </a:r>
+          </a:p>
+        </p:txBody>
+      </p:sp>
+      <p:sp>
+        <p:nvSpPr>
+          <p:cNvPr id="6" name="TextBox 5"/>
+          <p:cNvSpPr txBox="1"/>
+          <p:nvPr/>
+        </p:nvSpPr>
+        <p:spPr>
+          <a:xfrm>
+            <a:off x="731520" y="3931920"/>
+            <a:ext cx="13167360" cy="365760"/>
+          </a:xfrm>
+          <a:prstGeom prst="rect">
+            <a:avLst/>
+          </a:prstGeom>
+          <a:noFill/>
+        </p:spPr>
+        <p:txBody>
+          <a:bodyPr wrap="square" lIns="0" tIns="0" rIns="0" bIns="0">
+            <a:spAutoFit/>
+          </a:bodyPr>
+          <a:lstStyle/>
+          <a:p>
+            <a:pPr algn="l">
+              <a:defRPr sz="2000" b="1">
+                <a:solidFill>
+                  <a:srgbClr val="0F172A"/>
+                </a:solidFill>
+                <a:latin typeface="Segoe UI"/>
+              </a:defRPr>
+            </a:pPr>
+            <a:r>
+              <a:t>How the Ingestion Pipeline Operates</a:t>
+            </a:r>
+          </a:p>
+        </p:txBody>
+      </p:sp>
+      <p:sp>
+        <p:nvSpPr>
+          <p:cNvPr id="7" name="Rounded Rectangle 6"/>
+          <p:cNvSpPr/>
+          <p:nvPr/>
+        </p:nvSpPr>
+        <p:spPr>
+          <a:xfrm>
+            <a:off x="731520" y="4389120"/>
+            <a:ext cx="3108960" cy="2743200"/>
           </a:xfrm>
           <a:prstGeom prst="roundRect">
             <a:avLst/>
@@ -7098,14 +7406,14 @@
       </p:sp>
       <p:sp>
         <p:nvSpPr>
-          <p:cNvPr id="5" name="TextBox 4"/>
+          <p:cNvPr id="8" name="TextBox 7"/>
           <p:cNvSpPr txBox="1"/>
           <p:nvPr/>
         </p:nvSpPr>
         <p:spPr>
           <a:xfrm>
-            <a:off x="1097280" y="1920240"/>
-            <a:ext cx="5486400" cy="5303520"/>
+            <a:off x="914400" y="4663440"/>
+            <a:ext cx="2743200" cy="2194560"/>
           </a:xfrm>
           <a:prstGeom prst="rect">
             <a:avLst/>
@@ -7120,41 +7428,22 @@
           <a:p>
             <a:pPr>
               <a:spcAft>
-                <a:spcPts val="1600"/>
-              </a:spcAft>
-              <a:defRPr sz="2400" b="1">
+                <a:spcPts val="800"/>
+              </a:spcAft>
+              <a:defRPr sz="1600" b="1">
                 <a:solidFill>
                   <a:srgbClr val="4F46E5"/>
                 </a:solidFill>
-                <a:latin typeface="Trebuchet MS"/>
-              </a:defRPr>
-            </a:pPr>
-            <a:r>
-              <a:t>Solving the Render OOM Problem</a:t>
-            </a:r>
-          </a:p>
-          <a:p>
-            <a:pPr>
-              <a:spcAft>
-                <a:spcPts val="200"/>
-              </a:spcAft>
-              <a:defRPr b="1" sz="1600">
-                <a:solidFill>
-                  <a:srgbClr val="0F172A"/>
-                </a:solidFill>
-                <a:latin typeface="Segoe UI"/>
-              </a:defRPr>
-            </a:pPr>
-            <a:r>
-              <a:t>•  The Constraint: 512MB RAM Limit:</a:t>
-            </a:r>
-          </a:p>
-          <a:p>
-            <a:pPr>
-              <a:spcAft>
-                <a:spcPts val="1400"/>
-              </a:spcAft>
-              <a:defRPr sz="1400">
+                <a:latin typeface="Segoe UI"/>
+              </a:defRPr>
+            </a:pPr>
+            <a:r>
+              <a:t>1. FastAPI Endpoint</a:t>
+            </a:r>
+          </a:p>
+          <a:p>
+            <a:pPr>
+              <a:defRPr sz="1300">
                 <a:solidFill>
                   <a:srgbClr val="475569"/>
                 </a:solidFill>
@@ -7162,85 +7451,21 @@
               </a:defRPr>
             </a:pPr>
             <a:r>
-              <a:t>Free hosting services like Render enforce a strict 512MB memory ceiling. Loading PyTorch and local models inside the app led to instant Out-Of-Memory (OOM) crashes.</a:t>
-            </a:r>
-          </a:p>
-          <a:p>
-            <a:pPr>
-              <a:spcAft>
-                <a:spcPts val="200"/>
-              </a:spcAft>
-              <a:defRPr b="1" sz="1600">
-                <a:solidFill>
-                  <a:srgbClr val="0F172A"/>
-                </a:solidFill>
-                <a:latin typeface="Segoe UI"/>
-              </a:defRPr>
-            </a:pPr>
-            <a:r>
-              <a:t>•  The Design Shift: Serverless APIs:</a:t>
-            </a:r>
-          </a:p>
-          <a:p>
-            <a:pPr>
-              <a:spcAft>
-                <a:spcPts val="1400"/>
-              </a:spcAft>
-              <a:defRPr sz="1400">
-                <a:solidFill>
-                  <a:srgbClr val="475569"/>
-                </a:solidFill>
-                <a:latin typeface="Segoe UI"/>
-              </a:defRPr>
-            </a:pPr>
-            <a:r>
-              <a:t>I shifted from local `sentence-transformers` library to the Hugging Face Serverless Inference API to compute embeddings.</a:t>
-            </a:r>
-          </a:p>
-          <a:p>
-            <a:pPr>
-              <a:spcAft>
-                <a:spcPts val="200"/>
-              </a:spcAft>
-              <a:defRPr b="1" sz="1600">
-                <a:solidFill>
-                  <a:srgbClr val="0F172A"/>
-                </a:solidFill>
-                <a:latin typeface="Segoe UI"/>
-              </a:defRPr>
-            </a:pPr>
-            <a:r>
-              <a:t>•  The Result: Near-Zero Memory:</a:t>
-            </a:r>
-          </a:p>
-          <a:p>
-            <a:pPr>
-              <a:spcAft>
-                <a:spcPts val="1400"/>
-              </a:spcAft>
-              <a:defRPr sz="1400">
-                <a:solidFill>
-                  <a:srgbClr val="475569"/>
-                </a:solidFill>
-                <a:latin typeface="Segoe UI"/>
-              </a:defRPr>
-            </a:pPr>
-            <a:r>
-              <a:t>Embedding calculations are offloaded entirely. Memory footprints dropped to near-zero, while keeping the 384-dimensional vector database mapping 100% compatible.</a:t>
-            </a:r>
-          </a:p>
-        </p:txBody>
-      </p:sp>
-      <p:sp>
-        <p:nvSpPr>
-          <p:cNvPr id="6" name="Rounded Rectangle 5"/>
+              <a:t>Accepts multipart file upload and hands off to FastAPI background task.</a:t>
+            </a:r>
+          </a:p>
+        </p:txBody>
+      </p:sp>
+      <p:sp>
+        <p:nvSpPr>
+          <p:cNvPr id="9" name="Rounded Rectangle 8"/>
           <p:cNvSpPr/>
           <p:nvPr/>
         </p:nvSpPr>
         <p:spPr>
           <a:xfrm>
-            <a:off x="7680960" y="1645920"/>
-            <a:ext cx="6217920" cy="5852160"/>
+            <a:off x="4023360" y="4389120"/>
+            <a:ext cx="3108960" cy="2743200"/>
           </a:xfrm>
           <a:prstGeom prst="roundRect">
             <a:avLst/>
@@ -7250,7 +7475,7 @@
           </a:solidFill>
           <a:ln w="12700">
             <a:solidFill>
-              <a:srgbClr val="E2E8F0"/>
+              <a:srgbClr val="4F46E5"/>
             </a:solidFill>
           </a:ln>
         </p:spPr>
@@ -7278,14 +7503,14 @@
       </p:sp>
       <p:sp>
         <p:nvSpPr>
-          <p:cNvPr id="7" name="TextBox 6"/>
+          <p:cNvPr id="10" name="TextBox 9"/>
           <p:cNvSpPr txBox="1"/>
           <p:nvPr/>
         </p:nvSpPr>
         <p:spPr>
           <a:xfrm>
-            <a:off x="8046720" y="1920240"/>
-            <a:ext cx="5486400" cy="5303520"/>
+            <a:off x="4206240" y="4663440"/>
+            <a:ext cx="2743200" cy="2194560"/>
           </a:xfrm>
           <a:prstGeom prst="rect">
             <a:avLst/>
@@ -7300,41 +7525,22 @@
           <a:p>
             <a:pPr>
               <a:spcAft>
-                <a:spcPts val="1600"/>
-              </a:spcAft>
-              <a:defRPr sz="2400" b="1">
-                <a:solidFill>
-                  <a:srgbClr val="0F172A"/>
-                </a:solidFill>
-                <a:latin typeface="Trebuchet MS"/>
-              </a:defRPr>
-            </a:pPr>
-            <a:r>
-              <a:t>Intelligent Session Memory</a:t>
-            </a:r>
-          </a:p>
-          <a:p>
-            <a:pPr>
-              <a:spcAft>
-                <a:spcPts val="200"/>
-              </a:spcAft>
-              <a:defRPr b="1" sz="1600">
-                <a:solidFill>
-                  <a:srgbClr val="0F172A"/>
-                </a:solidFill>
-                <a:latin typeface="Segoe UI"/>
-              </a:defRPr>
-            </a:pPr>
-            <a:r>
-              <a:t>•  PostgreSQL-Backed Memory:</a:t>
-            </a:r>
-          </a:p>
-          <a:p>
-            <a:pPr>
-              <a:spcAft>
-                <a:spcPts val="1400"/>
-              </a:spcAft>
-              <a:defRPr sz="1400">
+                <a:spcPts val="800"/>
+              </a:spcAft>
+              <a:defRPr sz="1600" b="1">
+                <a:solidFill>
+                  <a:srgbClr val="4F46E5"/>
+                </a:solidFill>
+                <a:latin typeface="Segoe UI"/>
+              </a:defRPr>
+            </a:pPr>
+            <a:r>
+              <a:t>2. Extraction &amp; Clean</a:t>
+            </a:r>
+          </a:p>
+          <a:p>
+            <a:pPr>
+              <a:defRPr sz="1300">
                 <a:solidFill>
                   <a:srgbClr val="475569"/>
                 </a:solidFill>
@@ -7342,31 +7548,96 @@
               </a:defRPr>
             </a:pPr>
             <a:r>
-              <a:t>Conversation states are serialized and loaded directly from PostgreSQL databases based on persistent conversation UUIDs.</a:t>
-            </a:r>
-          </a:p>
-          <a:p>
-            <a:pPr>
-              <a:spcAft>
-                <a:spcPts val="200"/>
-              </a:spcAft>
-              <a:defRPr b="1" sz="1600">
-                <a:solidFill>
-                  <a:srgbClr val="0F172A"/>
-                </a:solidFill>
-                <a:latin typeface="Segoe UI"/>
-              </a:defRPr>
-            </a:pPr>
-            <a:r>
-              <a:t>•  Sliding Window Pruning:</a:t>
-            </a:r>
-          </a:p>
-          <a:p>
-            <a:pPr>
-              <a:spcAft>
-                <a:spcPts val="1400"/>
-              </a:spcAft>
-              <a:defRPr sz="1400">
+              <a:t>Saves temporarily, extracts text (OCR/Parser), and strips extra whitespace.</a:t>
+            </a:r>
+          </a:p>
+        </p:txBody>
+      </p:sp>
+      <p:sp>
+        <p:nvSpPr>
+          <p:cNvPr id="11" name="Rounded Rectangle 10"/>
+          <p:cNvSpPr/>
+          <p:nvPr/>
+        </p:nvSpPr>
+        <p:spPr>
+          <a:xfrm>
+            <a:off x="7315200" y="4389120"/>
+            <a:ext cx="3108960" cy="2743200"/>
+          </a:xfrm>
+          <a:prstGeom prst="roundRect">
+            <a:avLst/>
+          </a:prstGeom>
+          <a:solidFill>
+            <a:srgbClr val="FFFFFF"/>
+          </a:solidFill>
+          <a:ln w="12700">
+            <a:solidFill>
+              <a:srgbClr val="4F46E5"/>
+            </a:solidFill>
+          </a:ln>
+        </p:spPr>
+        <p:style>
+          <a:lnRef idx="1">
+            <a:schemeClr val="accent1"/>
+          </a:lnRef>
+          <a:fillRef idx="3">
+            <a:schemeClr val="accent1"/>
+          </a:fillRef>
+          <a:effectRef idx="2">
+            <a:schemeClr val="accent1"/>
+          </a:effectRef>
+          <a:fontRef idx="minor">
+            <a:schemeClr val="lt1"/>
+          </a:fontRef>
+        </p:style>
+        <p:txBody>
+          <a:bodyPr rtlCol="0" anchor="ctr"/>
+          <a:lstStyle/>
+          <a:p>
+            <a:pPr algn="ctr"/>
+          </a:p>
+        </p:txBody>
+      </p:sp>
+      <p:sp>
+        <p:nvSpPr>
+          <p:cNvPr id="12" name="TextBox 11"/>
+          <p:cNvSpPr txBox="1"/>
+          <p:nvPr/>
+        </p:nvSpPr>
+        <p:spPr>
+          <a:xfrm>
+            <a:off x="7498080" y="4663440"/>
+            <a:ext cx="2743200" cy="2194560"/>
+          </a:xfrm>
+          <a:prstGeom prst="rect">
+            <a:avLst/>
+          </a:prstGeom>
+          <a:noFill/>
+        </p:spPr>
+        <p:txBody>
+          <a:bodyPr wrap="square" lIns="0" tIns="0" rIns="0" bIns="0">
+            <a:spAutoFit/>
+          </a:bodyPr>
+          <a:lstStyle/>
+          <a:p>
+            <a:pPr>
+              <a:spcAft>
+                <a:spcPts val="800"/>
+              </a:spcAft>
+              <a:defRPr sz="1600" b="1">
+                <a:solidFill>
+                  <a:srgbClr val="4F46E5"/>
+                </a:solidFill>
+                <a:latin typeface="Segoe UI"/>
+              </a:defRPr>
+            </a:pPr>
+            <a:r>
+              <a:t>3. Chunking &amp; Overlap</a:t>
+            </a:r>
+          </a:p>
+          <a:p>
+            <a:pPr>
+              <a:defRPr sz="1300">
                 <a:solidFill>
                   <a:srgbClr val="475569"/>
                 </a:solidFill>
@@ -7374,31 +7645,96 @@
               </a:defRPr>
             </a:pPr>
             <a:r>
-              <a:t>Coded with an active sliding window of the last 10 messages. Older history is dynamically pruned from active contexts during requests.</a:t>
-            </a:r>
-          </a:p>
-          <a:p>
-            <a:pPr>
-              <a:spcAft>
-                <a:spcPts val="200"/>
-              </a:spcAft>
-              <a:defRPr b="1" sz="1600">
-                <a:solidFill>
-                  <a:srgbClr val="0F172A"/>
-                </a:solidFill>
-                <a:latin typeface="Segoe UI"/>
-              </a:defRPr>
-            </a:pPr>
-            <a:r>
-              <a:t>•  Optimizing Latency &amp; Accuracy:</a:t>
-            </a:r>
-          </a:p>
-          <a:p>
-            <a:pPr>
-              <a:spcAft>
-                <a:spcPts val="1400"/>
-              </a:spcAft>
-              <a:defRPr sz="1400">
+              <a:t>Chunks clean text using sliding thresholds (15 lines per chunk, 5 lines overlap).</a:t>
+            </a:r>
+          </a:p>
+        </p:txBody>
+      </p:sp>
+      <p:sp>
+        <p:nvSpPr>
+          <p:cNvPr id="13" name="Rounded Rectangle 12"/>
+          <p:cNvSpPr/>
+          <p:nvPr/>
+        </p:nvSpPr>
+        <p:spPr>
+          <a:xfrm>
+            <a:off x="10607040" y="4389120"/>
+            <a:ext cx="3291840" cy="2743200"/>
+          </a:xfrm>
+          <a:prstGeom prst="roundRect">
+            <a:avLst/>
+          </a:prstGeom>
+          <a:solidFill>
+            <a:srgbClr val="FFFFFF"/>
+          </a:solidFill>
+          <a:ln w="12700">
+            <a:solidFill>
+              <a:srgbClr val="4F46E5"/>
+            </a:solidFill>
+          </a:ln>
+        </p:spPr>
+        <p:style>
+          <a:lnRef idx="1">
+            <a:schemeClr val="accent1"/>
+          </a:lnRef>
+          <a:fillRef idx="3">
+            <a:schemeClr val="accent1"/>
+          </a:fillRef>
+          <a:effectRef idx="2">
+            <a:schemeClr val="accent1"/>
+          </a:effectRef>
+          <a:fontRef idx="minor">
+            <a:schemeClr val="lt1"/>
+          </a:fontRef>
+        </p:style>
+        <p:txBody>
+          <a:bodyPr rtlCol="0" anchor="ctr"/>
+          <a:lstStyle/>
+          <a:p>
+            <a:pPr algn="ctr"/>
+          </a:p>
+        </p:txBody>
+      </p:sp>
+      <p:sp>
+        <p:nvSpPr>
+          <p:cNvPr id="14" name="TextBox 13"/>
+          <p:cNvSpPr txBox="1"/>
+          <p:nvPr/>
+        </p:nvSpPr>
+        <p:spPr>
+          <a:xfrm>
+            <a:off x="10789920" y="4663440"/>
+            <a:ext cx="2926080" cy="2194560"/>
+          </a:xfrm>
+          <a:prstGeom prst="rect">
+            <a:avLst/>
+          </a:prstGeom>
+          <a:noFill/>
+        </p:spPr>
+        <p:txBody>
+          <a:bodyPr wrap="square" lIns="0" tIns="0" rIns="0" bIns="0">
+            <a:spAutoFit/>
+          </a:bodyPr>
+          <a:lstStyle/>
+          <a:p>
+            <a:pPr>
+              <a:spcAft>
+                <a:spcPts val="800"/>
+              </a:spcAft>
+              <a:defRPr sz="1600" b="1">
+                <a:solidFill>
+                  <a:srgbClr val="4F46E5"/>
+                </a:solidFill>
+                <a:latin typeface="Segoe UI"/>
+              </a:defRPr>
+            </a:pPr>
+            <a:r>
+              <a:t>4. pgvector Embedding</a:t>
+            </a:r>
+          </a:p>
+          <a:p>
+            <a:pPr>
+              <a:defRPr sz="1300">
                 <a:solidFill>
                   <a:srgbClr val="475569"/>
                 </a:solidFill>
@@ -7406,7 +7742,7 @@
               </a:defRPr>
             </a:pPr>
             <a:r>
-              <a:t>Capping history prevents model hallucinations, enforces clean conversation flows, and limits token usage to maintain fast API response times.</a:t>
+              <a:t>Embeds chunk text and persists to PostgreSQL with pgvector embeddings.</a:t>
             </a:r>
           </a:p>
         </p:txBody>
@@ -7511,7 +7847,7 @@
               </a:defRPr>
             </a:pPr>
             <a:r>
-              <a:t>Future Production-Ready Roadmap</a:t>
+              <a:t>DevOps Constraints &amp; Performance Optimizations</a:t>
             </a:r>
           </a:p>
         </p:txBody>
@@ -7525,7 +7861,187 @@
         <p:spPr>
           <a:xfrm>
             <a:off x="731520" y="1645920"/>
-            <a:ext cx="4023360" cy="5852160"/>
+            <a:ext cx="6217920" cy="5852160"/>
+          </a:xfrm>
+          <a:prstGeom prst="roundRect">
+            <a:avLst/>
+          </a:prstGeom>
+          <a:solidFill>
+            <a:srgbClr val="FFFFFF"/>
+          </a:solidFill>
+          <a:ln w="12700">
+            <a:solidFill>
+              <a:srgbClr val="4F46E5"/>
+            </a:solidFill>
+          </a:ln>
+        </p:spPr>
+        <p:style>
+          <a:lnRef idx="1">
+            <a:schemeClr val="accent1"/>
+          </a:lnRef>
+          <a:fillRef idx="3">
+            <a:schemeClr val="accent1"/>
+          </a:fillRef>
+          <a:effectRef idx="2">
+            <a:schemeClr val="accent1"/>
+          </a:effectRef>
+          <a:fontRef idx="minor">
+            <a:schemeClr val="lt1"/>
+          </a:fontRef>
+        </p:style>
+        <p:txBody>
+          <a:bodyPr rtlCol="0" anchor="ctr"/>
+          <a:lstStyle/>
+          <a:p>
+            <a:pPr algn="ctr"/>
+          </a:p>
+        </p:txBody>
+      </p:sp>
+      <p:sp>
+        <p:nvSpPr>
+          <p:cNvPr id="5" name="TextBox 4"/>
+          <p:cNvSpPr txBox="1"/>
+          <p:nvPr/>
+        </p:nvSpPr>
+        <p:spPr>
+          <a:xfrm>
+            <a:off x="1097280" y="1920240"/>
+            <a:ext cx="5486400" cy="5303520"/>
+          </a:xfrm>
+          <a:prstGeom prst="rect">
+            <a:avLst/>
+          </a:prstGeom>
+          <a:noFill/>
+        </p:spPr>
+        <p:txBody>
+          <a:bodyPr wrap="square" lIns="0" tIns="0" rIns="0" bIns="0">
+            <a:spAutoFit/>
+          </a:bodyPr>
+          <a:lstStyle/>
+          <a:p>
+            <a:pPr>
+              <a:spcAft>
+                <a:spcPts val="1600"/>
+              </a:spcAft>
+              <a:defRPr sz="2400" b="1">
+                <a:solidFill>
+                  <a:srgbClr val="4F46E5"/>
+                </a:solidFill>
+                <a:latin typeface="Trebuchet MS"/>
+              </a:defRPr>
+            </a:pPr>
+            <a:r>
+              <a:t>Solving the Render OOM Problem</a:t>
+            </a:r>
+          </a:p>
+          <a:p>
+            <a:pPr>
+              <a:spcAft>
+                <a:spcPts val="200"/>
+              </a:spcAft>
+              <a:defRPr b="1" sz="1600">
+                <a:solidFill>
+                  <a:srgbClr val="0F172A"/>
+                </a:solidFill>
+                <a:latin typeface="Segoe UI"/>
+              </a:defRPr>
+            </a:pPr>
+            <a:r>
+              <a:t>•  The Constraint: 512MB RAM Limit:</a:t>
+            </a:r>
+          </a:p>
+          <a:p>
+            <a:pPr>
+              <a:spcAft>
+                <a:spcPts val="1400"/>
+              </a:spcAft>
+              <a:defRPr sz="1400">
+                <a:solidFill>
+                  <a:srgbClr val="475569"/>
+                </a:solidFill>
+                <a:latin typeface="Segoe UI"/>
+              </a:defRPr>
+            </a:pPr>
+            <a:r>
+              <a:t>Free hosting services like Render enforce a strict 512MB memory ceiling. Loading PyTorch and local models inside the app led to instant Out-Of-Memory (OOM) crashes.</a:t>
+            </a:r>
+          </a:p>
+          <a:p>
+            <a:pPr>
+              <a:spcAft>
+                <a:spcPts val="200"/>
+              </a:spcAft>
+              <a:defRPr b="1" sz="1600">
+                <a:solidFill>
+                  <a:srgbClr val="0F172A"/>
+                </a:solidFill>
+                <a:latin typeface="Segoe UI"/>
+              </a:defRPr>
+            </a:pPr>
+            <a:r>
+              <a:t>•  The Design Shift: Serverless APIs:</a:t>
+            </a:r>
+          </a:p>
+          <a:p>
+            <a:pPr>
+              <a:spcAft>
+                <a:spcPts val="1400"/>
+              </a:spcAft>
+              <a:defRPr sz="1400">
+                <a:solidFill>
+                  <a:srgbClr val="475569"/>
+                </a:solidFill>
+                <a:latin typeface="Segoe UI"/>
+              </a:defRPr>
+            </a:pPr>
+            <a:r>
+              <a:t>I shifted from local `sentence-transformers` library to the Hugging Face Serverless Inference API to compute embeddings.</a:t>
+            </a:r>
+          </a:p>
+          <a:p>
+            <a:pPr>
+              <a:spcAft>
+                <a:spcPts val="200"/>
+              </a:spcAft>
+              <a:defRPr b="1" sz="1600">
+                <a:solidFill>
+                  <a:srgbClr val="0F172A"/>
+                </a:solidFill>
+                <a:latin typeface="Segoe UI"/>
+              </a:defRPr>
+            </a:pPr>
+            <a:r>
+              <a:t>•  The Result: Near-Zero Memory:</a:t>
+            </a:r>
+          </a:p>
+          <a:p>
+            <a:pPr>
+              <a:spcAft>
+                <a:spcPts val="1400"/>
+              </a:spcAft>
+              <a:defRPr sz="1400">
+                <a:solidFill>
+                  <a:srgbClr val="475569"/>
+                </a:solidFill>
+                <a:latin typeface="Segoe UI"/>
+              </a:defRPr>
+            </a:pPr>
+            <a:r>
+              <a:t>Embedding calculations are offloaded entirely. Memory footprints dropped to near-zero, while keeping the 384-dimensional vector database mapping 100% compatible.</a:t>
+            </a:r>
+          </a:p>
+        </p:txBody>
+      </p:sp>
+      <p:sp>
+        <p:nvSpPr>
+          <p:cNvPr id="6" name="Rounded Rectangle 5"/>
+          <p:cNvSpPr/>
+          <p:nvPr/>
+        </p:nvSpPr>
+        <p:spPr>
+          <a:xfrm>
+            <a:off x="7680960" y="1645920"/>
+            <a:ext cx="6217920" cy="5852160"/>
           </a:xfrm>
           <a:prstGeom prst="roundRect">
             <a:avLst/>
@@ -7563,14 +8079,14 @@
       </p:sp>
       <p:sp>
         <p:nvSpPr>
-          <p:cNvPr id="5" name="TextBox 4"/>
+          <p:cNvPr id="7" name="TextBox 6"/>
           <p:cNvSpPr txBox="1"/>
           <p:nvPr/>
         </p:nvSpPr>
         <p:spPr>
           <a:xfrm>
-            <a:off x="1005840" y="1920240"/>
-            <a:ext cx="3474720" cy="5303520"/>
+            <a:off x="8046720" y="1920240"/>
+            <a:ext cx="5486400" cy="5303520"/>
           </a:xfrm>
           <a:prstGeom prst="rect">
             <a:avLst/>
@@ -7585,24 +8101,40 @@
           <a:p>
             <a:pPr>
               <a:spcAft>
+                <a:spcPts val="1600"/>
+              </a:spcAft>
+              <a:defRPr sz="2400" b="1">
+                <a:solidFill>
+                  <a:srgbClr val="0F172A"/>
+                </a:solidFill>
+                <a:latin typeface="Trebuchet MS"/>
+              </a:defRPr>
+            </a:pPr>
+            <a:r>
+              <a:t>Intelligent Session Memory</a:t>
+            </a:r>
+          </a:p>
+          <a:p>
+            <a:pPr>
+              <a:spcAft>
+                <a:spcPts val="200"/>
+              </a:spcAft>
+              <a:defRPr b="1" sz="1600">
+                <a:solidFill>
+                  <a:srgbClr val="0F172A"/>
+                </a:solidFill>
+                <a:latin typeface="Segoe UI"/>
+              </a:defRPr>
+            </a:pPr>
+            <a:r>
+              <a:t>•  PostgreSQL-Backed Memory:</a:t>
+            </a:r>
+          </a:p>
+          <a:p>
+            <a:pPr>
+              <a:spcAft>
                 <a:spcPts val="1400"/>
               </a:spcAft>
-              <a:defRPr sz="2000" b="1">
-                <a:solidFill>
-                  <a:srgbClr val="4F46E5"/>
-                </a:solidFill>
-                <a:latin typeface="Segoe UI"/>
-              </a:defRPr>
-            </a:pPr>
-            <a:r>
-              <a:t>Phase 1: Authorization Hardening</a:t>
-            </a:r>
-          </a:p>
-          <a:p>
-            <a:pPr>
-              <a:spcAft>
-                <a:spcPts val="1600"/>
-              </a:spcAft>
               <a:defRPr sz="1400">
                 <a:solidFill>
                   <a:srgbClr val="475569"/>
@@ -7611,13 +8143,29 @@
               </a:defRPr>
             </a:pPr>
             <a:r>
-              <a:t>• Replace the current simulated X-Vendor-ID header auth with secure JWT or OAuth 2.0 flows.</a:t>
-            </a:r>
-          </a:p>
-          <a:p>
-            <a:pPr>
-              <a:spcAft>
-                <a:spcPts val="1600"/>
+              <a:t>Conversation states are serialized and loaded directly from PostgreSQL databases based on persistent conversation UUIDs.</a:t>
+            </a:r>
+          </a:p>
+          <a:p>
+            <a:pPr>
+              <a:spcAft>
+                <a:spcPts val="200"/>
+              </a:spcAft>
+              <a:defRPr b="1" sz="1600">
+                <a:solidFill>
+                  <a:srgbClr val="0F172A"/>
+                </a:solidFill>
+                <a:latin typeface="Segoe UI"/>
+              </a:defRPr>
+            </a:pPr>
+            <a:r>
+              <a:t>•  Sliding Window Pruning:</a:t>
+            </a:r>
+          </a:p>
+          <a:p>
+            <a:pPr>
+              <a:spcAft>
+                <a:spcPts val="1400"/>
               </a:spcAft>
               <a:defRPr sz="1400">
                 <a:solidFill>
@@ -7627,98 +8175,30 @@
               </a:defRPr>
             </a:pPr>
             <a:r>
-              <a:t>• Implement Role-Based Access Control (RBAC): Admin roles auto-execute, while Staff roles route to Human-in-the-Loop approvals.</a:t>
-            </a:r>
-          </a:p>
-        </p:txBody>
-      </p:sp>
-      <p:sp>
-        <p:nvSpPr>
-          <p:cNvPr id="6" name="Rounded Rectangle 5"/>
-          <p:cNvSpPr/>
-          <p:nvPr/>
-        </p:nvSpPr>
-        <p:spPr>
-          <a:xfrm>
-            <a:off x="5303520" y="1645920"/>
-            <a:ext cx="4023360" cy="5852160"/>
-          </a:xfrm>
-          <a:prstGeom prst="roundRect">
-            <a:avLst/>
-          </a:prstGeom>
-          <a:solidFill>
-            <a:srgbClr val="FFFFFF"/>
-          </a:solidFill>
-          <a:ln w="12700">
-            <a:solidFill>
-              <a:srgbClr val="E2E8F0"/>
-            </a:solidFill>
-          </a:ln>
-        </p:spPr>
-        <p:style>
-          <a:lnRef idx="1">
-            <a:schemeClr val="accent1"/>
-          </a:lnRef>
-          <a:fillRef idx="3">
-            <a:schemeClr val="accent1"/>
-          </a:fillRef>
-          <a:effectRef idx="2">
-            <a:schemeClr val="accent1"/>
-          </a:effectRef>
-          <a:fontRef idx="minor">
-            <a:schemeClr val="lt1"/>
-          </a:fontRef>
-        </p:style>
-        <p:txBody>
-          <a:bodyPr rtlCol="0" anchor="ctr"/>
-          <a:lstStyle/>
-          <a:p>
-            <a:pPr algn="ctr"/>
-          </a:p>
-        </p:txBody>
-      </p:sp>
-      <p:sp>
-        <p:nvSpPr>
-          <p:cNvPr id="7" name="TextBox 6"/>
-          <p:cNvSpPr txBox="1"/>
-          <p:nvPr/>
-        </p:nvSpPr>
-        <p:spPr>
-          <a:xfrm>
-            <a:off x="5577840" y="1920240"/>
-            <a:ext cx="3474720" cy="5303520"/>
-          </a:xfrm>
-          <a:prstGeom prst="rect">
-            <a:avLst/>
-          </a:prstGeom>
-          <a:noFill/>
-        </p:spPr>
-        <p:txBody>
-          <a:bodyPr wrap="square" lIns="0" tIns="0" rIns="0" bIns="0">
-            <a:spAutoFit/>
-          </a:bodyPr>
-          <a:lstStyle/>
+              <a:t>Coded with an active sliding window of the last 10 messages. Older history is dynamically pruned from active contexts during requests.</a:t>
+            </a:r>
+          </a:p>
+          <a:p>
+            <a:pPr>
+              <a:spcAft>
+                <a:spcPts val="200"/>
+              </a:spcAft>
+              <a:defRPr b="1" sz="1600">
+                <a:solidFill>
+                  <a:srgbClr val="0F172A"/>
+                </a:solidFill>
+                <a:latin typeface="Segoe UI"/>
+              </a:defRPr>
+            </a:pPr>
+            <a:r>
+              <a:t>•  Optimizing Latency &amp; Accuracy:</a:t>
+            </a:r>
+          </a:p>
           <a:p>
             <a:pPr>
               <a:spcAft>
                 <a:spcPts val="1400"/>
               </a:spcAft>
-              <a:defRPr sz="2000" b="1">
-                <a:solidFill>
-                  <a:srgbClr val="4F46E5"/>
-                </a:solidFill>
-                <a:latin typeface="Segoe UI"/>
-              </a:defRPr>
-            </a:pPr>
-            <a:r>
-              <a:t>Phase 2: UX &amp; Stream Upgrades</a:t>
-            </a:r>
-          </a:p>
-          <a:p>
-            <a:pPr>
-              <a:spcAft>
-                <a:spcPts val="1600"/>
-              </a:spcAft>
               <a:defRPr sz="1400">
                 <a:solidFill>
                   <a:srgbClr val="475569"/>
@@ -7727,139 +8207,7 @@
               </a:defRPr>
             </a:pPr>
             <a:r>
-              <a:t>• Upgrade current REST endpoints to WebSockets to support real-time LLM token streaming.</a:t>
-            </a:r>
-          </a:p>
-          <a:p>
-            <a:pPr>
-              <a:spcAft>
-                <a:spcPts val="1600"/>
-              </a:spcAft>
-              <a:defRPr sz="1400">
-                <a:solidFill>
-                  <a:srgbClr val="475569"/>
-                </a:solidFill>
-                <a:latin typeface="Segoe UI"/>
-              </a:defRPr>
-            </a:pPr>
-            <a:r>
-              <a:t>• Add rich UI approval card breakdowns to preview exact user/game database details prior to execution.</a:t>
-            </a:r>
-          </a:p>
-        </p:txBody>
-      </p:sp>
-      <p:sp>
-        <p:nvSpPr>
-          <p:cNvPr id="8" name="Rounded Rectangle 7"/>
-          <p:cNvSpPr/>
-          <p:nvPr/>
-        </p:nvSpPr>
-        <p:spPr>
-          <a:xfrm>
-            <a:off x="9875520" y="1645920"/>
-            <a:ext cx="4023360" cy="5852160"/>
-          </a:xfrm>
-          <a:prstGeom prst="roundRect">
-            <a:avLst/>
-          </a:prstGeom>
-          <a:solidFill>
-            <a:srgbClr val="FFFFFF"/>
-          </a:solidFill>
-          <a:ln w="12700">
-            <a:solidFill>
-              <a:srgbClr val="E2E8F0"/>
-            </a:solidFill>
-          </a:ln>
-        </p:spPr>
-        <p:style>
-          <a:lnRef idx="1">
-            <a:schemeClr val="accent1"/>
-          </a:lnRef>
-          <a:fillRef idx="3">
-            <a:schemeClr val="accent1"/>
-          </a:fillRef>
-          <a:effectRef idx="2">
-            <a:schemeClr val="accent1"/>
-          </a:effectRef>
-          <a:fontRef idx="minor">
-            <a:schemeClr val="lt1"/>
-          </a:fontRef>
-        </p:style>
-        <p:txBody>
-          <a:bodyPr rtlCol="0" anchor="ctr"/>
-          <a:lstStyle/>
-          <a:p>
-            <a:pPr algn="ctr"/>
-          </a:p>
-        </p:txBody>
-      </p:sp>
-      <p:sp>
-        <p:nvSpPr>
-          <p:cNvPr id="9" name="TextBox 8"/>
-          <p:cNvSpPr txBox="1"/>
-          <p:nvPr/>
-        </p:nvSpPr>
-        <p:spPr>
-          <a:xfrm>
-            <a:off x="10149840" y="1920240"/>
-            <a:ext cx="3474720" cy="5303520"/>
-          </a:xfrm>
-          <a:prstGeom prst="rect">
-            <a:avLst/>
-          </a:prstGeom>
-          <a:noFill/>
-        </p:spPr>
-        <p:txBody>
-          <a:bodyPr wrap="square" lIns="0" tIns="0" rIns="0" bIns="0">
-            <a:spAutoFit/>
-          </a:bodyPr>
-          <a:lstStyle/>
-          <a:p>
-            <a:pPr>
-              <a:spcAft>
-                <a:spcPts val="1400"/>
-              </a:spcAft>
-              <a:defRPr sz="2000" b="1">
-                <a:solidFill>
-                  <a:srgbClr val="4F46E5"/>
-                </a:solidFill>
-                <a:latin typeface="Segoe UI"/>
-              </a:defRPr>
-            </a:pPr>
-            <a:r>
-              <a:t>Phase 3: Database &amp; CI Hardening</a:t>
-            </a:r>
-          </a:p>
-          <a:p>
-            <a:pPr>
-              <a:spcAft>
-                <a:spcPts val="1600"/>
-              </a:spcAft>
-              <a:defRPr sz="1400">
-                <a:solidFill>
-                  <a:srgbClr val="475569"/>
-                </a:solidFill>
-                <a:latin typeface="Segoe UI"/>
-              </a:defRPr>
-            </a:pPr>
-            <a:r>
-              <a:t>• Transition startup-based database creation to version-controlled Alembic migrations.</a:t>
-            </a:r>
-          </a:p>
-          <a:p>
-            <a:pPr>
-              <a:spcAft>
-                <a:spcPts val="1600"/>
-              </a:spcAft>
-              <a:defRPr sz="1400">
-                <a:solidFill>
-                  <a:srgbClr val="475569"/>
-                </a:solidFill>
-                <a:latin typeface="Segoe UI"/>
-              </a:defRPr>
-            </a:pPr>
-            <a:r>
-              <a:t>• Build a CI pipeline that runs safety tests automatically on pull requests.</a:t>
+              <a:t>Capping history prevents model hallucinations, enforces clean conversation flows, and limits token usage to maintain fast API response times.</a:t>
             </a:r>
           </a:p>
         </p:txBody>

</xml_diff>

<commit_message>
docs: correct screenshot labels in README and presentation
</commit_message>
<xml_diff>
--- a/HobbyFi_Presentation.pptx
+++ b/HobbyFi_Presentation.pptx
@@ -6982,7 +6982,7 @@
               </a:defRPr>
             </a:pPr>
             <a:r>
-              <a:t>Interactive Chat Interface</a:t>
+              <a:t>Human-in-the-Loop Approvals</a:t>
             </a:r>
           </a:p>
           <a:p>
@@ -6995,7 +6995,7 @@
               </a:defRPr>
             </a:pPr>
             <a:r>
-              <a:t>Features dynamic user-scoped conversation turns with runtime mode badges (Gemini mode, Local model, or Fallback responder).</a:t>
+              <a:t>Demonstrates a membership write mutation that requires approval, is approved via the UI card, and then successfully executed.</a:t>
             </a:r>
           </a:p>
         </p:txBody>
@@ -7103,7 +7103,7 @@
               </a:defRPr>
             </a:pPr>
             <a:r>
-              <a:t>Human-in-the-Loop Approvals</a:t>
+              <a:t>Multi-Tenant Guardrails</a:t>
             </a:r>
           </a:p>
           <a:p>
@@ -7116,7 +7116,7 @@
               </a:defRPr>
             </a:pPr>
             <a:r>
-              <a:t>Mutating CRM requests return a draft card where changes are locked until explicit approval, ensuring strict transactional safety.</a:t>
+              <a:t>Testing cross-vendor data queries (e.g. database dump request). The copilot securely refuses access, preventing information leaks.</a:t>
             </a:r>
           </a:p>
         </p:txBody>

</xml_diff>